<commit_message>
docs: finalize C02 result PPT v002
</commit_message>
<xml_diff>
--- a/Doc/cluster_analysis/C02_Chip_Acquisition/C02_Chip_Acquisition_Code_Fix_Result_20260430_v002.pptx
+++ b/Doc/cluster_analysis/C02_Chip_Acquisition/C02_Chip_Acquisition_Code_Fix_Result_20260430_v002.pptx
@@ -4,6 +4,9 @@
   <p:sldMasterIdLst>
     <p:sldMasterId id="2147483648" r:id="rId1"/>
   </p:sldMasterIdLst>
+  <p:notesMasterIdLst>
+    <p:notesMasterId r:id="rId9"/>
+  </p:notesMasterIdLst>
   <p:sldIdLst>
     <p:sldId id="256" r:id="rId2"/>
     <p:sldId id="257" r:id="rId3"/>
@@ -13,11 +16,8 @@
     <p:sldId id="261" r:id="rId7"/>
     <p:sldId id="262" r:id="rId8"/>
   </p:sldIdLst>
-  <p:notesMasterIdLst>
-    <p:notesMasterId r:id="rId9"/>
-  </p:notesMasterIdLst>
-  <p:sldSz cx="12191695" cy="6858000"/>
-  <p:notesSz cx="6858000" cy="12191695"/>
+  <p:sldSz cx="12192000" cy="6858000"/>
+  <p:notesSz cx="6858000" cy="12192000"/>
   <p:defaultTextStyle>
     <a:lvl1pPr marL="0" algn="l" defTabSz="914400" rtl="0" eaLnBrk="1" latinLnBrk="0" hangingPunct="1">
       <a:defRPr sz="1800" kern="1200">
@@ -110,6 +110,11 @@
       </a:defRPr>
     </a:lvl9pPr>
   </p:defaultTextStyle>
+  <p:extLst>
+    <p:ext uri="{EFAFB233-063F-42B5-8137-9DF3F51BA10A}">
+      <p15:sldGuideLst xmlns:p15="http://schemas.microsoft.com/office/powerpoint/2012/main"/>
+    </p:ext>
+  </p:extLst>
 </p:presentation>
 </file>
 
@@ -135,240 +140,16 @@
           <a:chExt cx="0" cy="0"/>
         </a:xfrm>
       </p:grpSpPr>
-      <p:sp>
-        <p:nvSpPr>
-          <p:cNvPr id="2" name="Header Placeholder 1"/>
-          <p:cNvSpPr>
-            <a:spLocks noGrp="1"/>
-          </p:cNvSpPr>
-          <p:nvPr>
-            <p:ph type="hdr" sz="quarter"/>
-          </p:nvPr>
-        </p:nvSpPr>
-        <p:spPr>
-          <a:xfrm>
-            <a:off x="0" y="0"/>
-            <a:ext cx="2971800" cy="458788"/>
-          </a:xfrm>
-          <a:prstGeom prst="rect">
-            <a:avLst/>
-          </a:prstGeom>
-        </p:spPr>
-        <p:txBody>
-          <a:bodyPr vert="horz" lIns="91440" tIns="45720" rIns="91440" bIns="45720" rtlCol="0"/>
-          <a:lstStyle>
-            <a:lvl1pPr algn="l">
-              <a:defRPr sz="1200"/>
-            </a:lvl1pPr>
-          </a:lstStyle>
-          <a:p>
-            <a:endParaRPr lang="en-US"/>
-          </a:p>
-        </p:txBody>
-      </p:sp>
-      <p:sp>
-        <p:nvSpPr>
-          <p:cNvPr id="3" name="Date Placeholder 2"/>
-          <p:cNvSpPr>
-            <a:spLocks noGrp="1"/>
-          </p:cNvSpPr>
-          <p:nvPr>
-            <p:ph type="dt" idx="1"/>
-          </p:nvPr>
-        </p:nvSpPr>
-        <p:spPr>
-          <a:xfrm>
-            <a:off x="3884613" y="0"/>
-            <a:ext cx="2971800" cy="458788"/>
-          </a:xfrm>
-          <a:prstGeom prst="rect">
-            <a:avLst/>
-          </a:prstGeom>
-        </p:spPr>
-        <p:txBody>
-          <a:bodyPr vert="horz" lIns="91440" tIns="45720" rIns="91440" bIns="45720" rtlCol="0"/>
-          <a:lstStyle>
-            <a:lvl1pPr algn="r">
-              <a:defRPr sz="1200"/>
-            </a:lvl1pPr>
-          </a:lstStyle>
-          <a:p>
-            <a:fld id="{5282F153-3F37-0F45-9E97-73ACFA13230C}" type="datetimeFigureOut">
-              <a:rPr lang="en-US"/>
-              <a:t>7/23/19</a:t>
-            </a:fld>
-            <a:endParaRPr lang="en-US"/>
-          </a:p>
-        </p:txBody>
-      </p:sp>
-      <p:sp>
-        <p:nvSpPr>
-          <p:cNvPr id="4" name="Slide Image Placeholder 3"/>
-          <p:cNvSpPr>
-            <a:spLocks noGrp="1" noRot="1" noChangeAspect="1"/>
-          </p:cNvSpPr>
-          <p:nvPr>
-            <p:ph type="sldImg" idx="2"/>
-          </p:nvPr>
-        </p:nvSpPr>
-        <p:spPr>
-          <a:xfrm>
-            <a:off x="685800" y="1143000"/>
-            <a:ext cx="5486400" cy="3086100"/>
-          </a:xfrm>
-          <a:prstGeom prst="rect">
-            <a:avLst/>
-          </a:prstGeom>
-          <a:noFill/>
-          <a:ln w="12700">
-            <a:solidFill>
-              <a:prstClr val="black"/>
-            </a:solidFill>
-          </a:ln>
-        </p:spPr>
-        <p:txBody>
-          <a:bodyPr vert="horz" lIns="91440" tIns="45720" rIns="91440" bIns="45720" rtlCol="0" anchor="ctr"/>
-          <a:lstStyle/>
-          <a:p>
-            <a:endParaRPr lang="en-US"/>
-          </a:p>
-        </p:txBody>
-      </p:sp>
-      <p:sp>
-        <p:nvSpPr>
-          <p:cNvPr id="5" name="Notes Placeholder 4"/>
-          <p:cNvSpPr>
-            <a:spLocks noGrp="1"/>
-          </p:cNvSpPr>
-          <p:nvPr>
-            <p:ph type="body" sz="quarter" idx="3"/>
-          </p:nvPr>
-        </p:nvSpPr>
-        <p:spPr>
-          <a:xfrm>
-            <a:off x="685800" y="4400550"/>
-            <a:ext cx="5486400" cy="3600450"/>
-          </a:xfrm>
-          <a:prstGeom prst="rect">
-            <a:avLst/>
-          </a:prstGeom>
-        </p:spPr>
-        <p:txBody>
-          <a:bodyPr vert="horz" lIns="91440" tIns="45720" rIns="91440" bIns="45720" rtlCol="0"/>
-          <a:lstStyle/>
-          <a:p>
-            <a:pPr lvl="0"/>
-            <a:r>
-              <a:rPr lang="en-US"/>
-              <a:t>Click to edit Master text styles</a:t>
-            </a:r>
-          </a:p>
-          <a:p>
-            <a:pPr lvl="1"/>
-            <a:r>
-              <a:rPr lang="en-US"/>
-              <a:t>Second level</a:t>
-            </a:r>
-          </a:p>
-          <a:p>
-            <a:pPr lvl="2"/>
-            <a:r>
-              <a:rPr lang="en-US"/>
-              <a:t>Third level</a:t>
-            </a:r>
-          </a:p>
-          <a:p>
-            <a:pPr lvl="3"/>
-            <a:r>
-              <a:rPr lang="en-US"/>
-              <a:t>Fourth level</a:t>
-            </a:r>
-          </a:p>
-          <a:p>
-            <a:pPr lvl="4"/>
-            <a:r>
-              <a:rPr lang="en-US"/>
-              <a:t>Fifth level</a:t>
-            </a:r>
-          </a:p>
-        </p:txBody>
-      </p:sp>
-      <p:sp>
-        <p:nvSpPr>
-          <p:cNvPr id="6" name="Footer Placeholder 5"/>
-          <p:cNvSpPr>
-            <a:spLocks noGrp="1"/>
-          </p:cNvSpPr>
-          <p:nvPr>
-            <p:ph type="ftr" sz="quarter" idx="4"/>
-          </p:nvPr>
-        </p:nvSpPr>
-        <p:spPr>
-          <a:xfrm>
-            <a:off x="0" y="8685213"/>
-            <a:ext cx="2971800" cy="458787"/>
-          </a:xfrm>
-          <a:prstGeom prst="rect">
-            <a:avLst/>
-          </a:prstGeom>
-        </p:spPr>
-        <p:txBody>
-          <a:bodyPr vert="horz" lIns="91440" tIns="45720" rIns="91440" bIns="45720" rtlCol="0" anchor="b"/>
-          <a:lstStyle>
-            <a:lvl1pPr algn="l">
-              <a:defRPr sz="1200"/>
-            </a:lvl1pPr>
-          </a:lstStyle>
-          <a:p>
-            <a:endParaRPr lang="en-US"/>
-          </a:p>
-        </p:txBody>
-      </p:sp>
-      <p:sp>
-        <p:nvSpPr>
-          <p:cNvPr id="7" name="Slide Number Placeholder 6"/>
-          <p:cNvSpPr>
-            <a:spLocks noGrp="1"/>
-          </p:cNvSpPr>
-          <p:nvPr>
-            <p:ph type="sldNum" sz="quarter" idx="5"/>
-          </p:nvPr>
-        </p:nvSpPr>
-        <p:spPr>
-          <a:xfrm>
-            <a:off x="3884613" y="8685213"/>
-            <a:ext cx="2971800" cy="458787"/>
-          </a:xfrm>
-          <a:prstGeom prst="rect">
-            <a:avLst/>
-          </a:prstGeom>
-        </p:spPr>
-        <p:txBody>
-          <a:bodyPr vert="horz" lIns="91440" tIns="45720" rIns="91440" bIns="45720" rtlCol="0" anchor="b"/>
-          <a:lstStyle>
-            <a:lvl1pPr algn="r">
-              <a:defRPr sz="1200"/>
-            </a:lvl1pPr>
-          </a:lstStyle>
-          <a:p>
-            <a:fld id="{CE5E9CC1-C706-0F49-92D6-E571CC5EEA8F}" type="slidenum">
-              <a:rPr lang="en-US"/>
-              <a:t>‹#›</a:t>
-            </a:fld>
-            <a:endParaRPr lang="en-US"/>
-          </a:p>
-        </p:txBody>
-      </p:sp>
     </p:spTree>
     <p:extLst>
       <p:ext uri="{BB962C8B-B14F-4D97-AF65-F5344CB8AC3E}">
-        <p14:creationId xmlns:p14="http://schemas.microsoft.com/office/powerpoint/2010/main" val="1024086991"/>
+        <p14:creationId xmlns:p14="http://schemas.microsoft.com/office/powerpoint/2010/main" val="1154988266"/>
       </p:ext>
     </p:extLst>
   </p:cSld>
   <p:clrMap bg1="lt1" tx1="dk1" bg2="lt2" tx2="dk2" accent1="accent1" accent2="accent2" accent3="accent3" accent4="accent4" accent5="accent5" accent6="accent6" hlink="hlink" folHlink="folHlink"/>
   <p:notesStyle>
-    <a:lvl1pPr marL="0" algn="l" defTabSz="914400" rtl="0" eaLnBrk="1" latinLnBrk="0" hangingPunct="1">
+    <a:lvl1pPr marL="0" algn="l" defTabSz="914400" rtl="0" eaLnBrk="1" latinLnBrk="1" hangingPunct="1">
       <a:defRPr sz="1200" kern="1200">
         <a:solidFill>
           <a:schemeClr val="tx1"/>
@@ -378,7 +159,7 @@
         <a:cs typeface="+mn-cs"/>
       </a:defRPr>
     </a:lvl1pPr>
-    <a:lvl2pPr marL="457200" algn="l" defTabSz="914400" rtl="0" eaLnBrk="1" latinLnBrk="0" hangingPunct="1">
+    <a:lvl2pPr marL="457200" algn="l" defTabSz="914400" rtl="0" eaLnBrk="1" latinLnBrk="1" hangingPunct="1">
       <a:defRPr sz="1200" kern="1200">
         <a:solidFill>
           <a:schemeClr val="tx1"/>
@@ -388,7 +169,7 @@
         <a:cs typeface="+mn-cs"/>
       </a:defRPr>
     </a:lvl2pPr>
-    <a:lvl3pPr marL="914400" algn="l" defTabSz="914400" rtl="0" eaLnBrk="1" latinLnBrk="0" hangingPunct="1">
+    <a:lvl3pPr marL="914400" algn="l" defTabSz="914400" rtl="0" eaLnBrk="1" latinLnBrk="1" hangingPunct="1">
       <a:defRPr sz="1200" kern="1200">
         <a:solidFill>
           <a:schemeClr val="tx1"/>
@@ -398,7 +179,7 @@
         <a:cs typeface="+mn-cs"/>
       </a:defRPr>
     </a:lvl3pPr>
-    <a:lvl4pPr marL="1371600" algn="l" defTabSz="914400" rtl="0" eaLnBrk="1" latinLnBrk="0" hangingPunct="1">
+    <a:lvl4pPr marL="1371600" algn="l" defTabSz="914400" rtl="0" eaLnBrk="1" latinLnBrk="1" hangingPunct="1">
       <a:defRPr sz="1200" kern="1200">
         <a:solidFill>
           <a:schemeClr val="tx1"/>
@@ -408,7 +189,7 @@
         <a:cs typeface="+mn-cs"/>
       </a:defRPr>
     </a:lvl4pPr>
-    <a:lvl5pPr marL="1828800" algn="l" defTabSz="914400" rtl="0" eaLnBrk="1" latinLnBrk="0" hangingPunct="1">
+    <a:lvl5pPr marL="1828800" algn="l" defTabSz="914400" rtl="0" eaLnBrk="1" latinLnBrk="1" hangingPunct="1">
       <a:defRPr sz="1200" kern="1200">
         <a:solidFill>
           <a:schemeClr val="tx1"/>
@@ -418,7 +199,7 @@
         <a:cs typeface="+mn-cs"/>
       </a:defRPr>
     </a:lvl5pPr>
-    <a:lvl6pPr marL="2286000" algn="l" defTabSz="914400" rtl="0" eaLnBrk="1" latinLnBrk="0" hangingPunct="1">
+    <a:lvl6pPr marL="2286000" algn="l" defTabSz="914400" rtl="0" eaLnBrk="1" latinLnBrk="1" hangingPunct="1">
       <a:defRPr sz="1200" kern="1200">
         <a:solidFill>
           <a:schemeClr val="tx1"/>
@@ -428,7 +209,7 @@
         <a:cs typeface="+mn-cs"/>
       </a:defRPr>
     </a:lvl6pPr>
-    <a:lvl7pPr marL="2743200" algn="l" defTabSz="914400" rtl="0" eaLnBrk="1" latinLnBrk="0" hangingPunct="1">
+    <a:lvl7pPr marL="2743200" algn="l" defTabSz="914400" rtl="0" eaLnBrk="1" latinLnBrk="1" hangingPunct="1">
       <a:defRPr sz="1200" kern="1200">
         <a:solidFill>
           <a:schemeClr val="tx1"/>
@@ -438,7 +219,7 @@
         <a:cs typeface="+mn-cs"/>
       </a:defRPr>
     </a:lvl7pPr>
-    <a:lvl8pPr marL="3200400" algn="l" defTabSz="914400" rtl="0" eaLnBrk="1" latinLnBrk="0" hangingPunct="1">
+    <a:lvl8pPr marL="3200400" algn="l" defTabSz="914400" rtl="0" eaLnBrk="1" latinLnBrk="1" hangingPunct="1">
       <a:defRPr sz="1200" kern="1200">
         <a:solidFill>
           <a:schemeClr val="tx1"/>
@@ -448,7 +229,7 @@
         <a:cs typeface="+mn-cs"/>
       </a:defRPr>
     </a:lvl8pPr>
-    <a:lvl9pPr marL="3657600" algn="l" defTabSz="914400" rtl="0" eaLnBrk="1" latinLnBrk="0" hangingPunct="1">
+    <a:lvl9pPr marL="3657600" algn="l" defTabSz="914400" rtl="0" eaLnBrk="1" latinLnBrk="1" hangingPunct="1">
       <a:defRPr sz="1200" kern="1200">
         <a:solidFill>
           <a:schemeClr val="tx1"/>
@@ -506,10 +287,6 @@
           <a:bodyPr/>
           <a:lstStyle/>
           <a:p>
-            <a:r>
-              <a:rPr lang="en-US" dirty="0"/>
-              <a:t/>
-            </a:r>
             <a:endParaRPr lang="en-US" dirty="0"/>
           </a:p>
         </p:txBody>
@@ -594,10 +371,6 @@
           <a:bodyPr/>
           <a:lstStyle/>
           <a:p>
-            <a:r>
-              <a:rPr lang="en-US" dirty="0"/>
-              <a:t/>
-            </a:r>
             <a:endParaRPr lang="en-US" dirty="0"/>
           </a:p>
         </p:txBody>
@@ -682,10 +455,6 @@
           <a:bodyPr/>
           <a:lstStyle/>
           <a:p>
-            <a:r>
-              <a:rPr lang="en-US" dirty="0"/>
-              <a:t/>
-            </a:r>
             <a:endParaRPr lang="en-US" dirty="0"/>
           </a:p>
         </p:txBody>
@@ -770,10 +539,6 @@
           <a:bodyPr/>
           <a:lstStyle/>
           <a:p>
-            <a:r>
-              <a:rPr lang="en-US" dirty="0"/>
-              <a:t/>
-            </a:r>
             <a:endParaRPr lang="en-US" dirty="0"/>
           </a:p>
         </p:txBody>
@@ -858,10 +623,6 @@
           <a:bodyPr/>
           <a:lstStyle/>
           <a:p>
-            <a:r>
-              <a:rPr lang="en-US" dirty="0"/>
-              <a:t/>
-            </a:r>
             <a:endParaRPr lang="en-US" dirty="0"/>
           </a:p>
         </p:txBody>
@@ -946,10 +707,6 @@
           <a:bodyPr/>
           <a:lstStyle/>
           <a:p>
-            <a:r>
-              <a:rPr lang="en-US" dirty="0"/>
-              <a:t/>
-            </a:r>
             <a:endParaRPr lang="en-US" dirty="0"/>
           </a:p>
         </p:txBody>
@@ -1034,10 +791,6 @@
           <a:bodyPr/>
           <a:lstStyle/>
           <a:p>
-            <a:r>
-              <a:rPr lang="en-US" dirty="0"/>
-              <a:t/>
-            </a:r>
             <a:endParaRPr lang="en-US" dirty="0"/>
           </a:p>
         </p:txBody>
@@ -1111,6 +864,11 @@
 <file path=ppt/slideMasters/slideMaster1.xml><?xml version="1.0" encoding="utf-8"?>
 <p:sldMaster xmlns:a="http://schemas.openxmlformats.org/drawingml/2006/main" xmlns:r="http://schemas.openxmlformats.org/officeDocument/2006/relationships" xmlns:p="http://schemas.openxmlformats.org/presentationml/2006/main">
   <p:cSld>
+    <p:bg>
+      <p:bgRef idx="1001">
+        <a:schemeClr val="bg1"/>
+      </p:bgRef>
+    </p:bg>
     <p:spTree>
       <p:nvGrpSpPr>
         <p:cNvPr id="1" name=""/>
@@ -1393,6 +1151,7 @@
         <a:solidFill>
           <a:srgbClr val="F7F9FA"/>
         </a:solidFill>
+        <a:effectLst/>
       </p:bgPr>
     </p:bg>
     <p:spTree>
@@ -1430,7 +1189,7 @@
           <a:bodyPr wrap="square" lIns="0" tIns="0" rIns="0" bIns="0" rtlCol="0" anchor="ctr"/>
           <a:lstStyle/>
           <a:p>
-            <a:pPr indent="0" marL="0">
+            <a:pPr marL="0" indent="0">
               <a:buNone/>
             </a:pPr>
             <a:r>
@@ -1469,7 +1228,7 @@
           <a:bodyPr wrap="square" lIns="0" tIns="0" rIns="0" bIns="0" rtlCol="0" anchor="ctr"/>
           <a:lstStyle/>
           <a:p>
-            <a:pPr indent="0" marL="0">
+            <a:pPr marL="0" indent="0">
               <a:buNone/>
             </a:pPr>
             <a:r>
@@ -1537,7 +1296,7 @@
           </a:bodyPr>
           <a:lstStyle/>
           <a:p>
-            <a:pPr algn="ctr" indent="0" marL="0">
+            <a:pPr marL="0" indent="0" algn="ctr">
               <a:buNone/>
             </a:pPr>
             <a:r>
@@ -1554,7 +1313,7 @@
             <a:endParaRPr lang="en-US" sz="1350" dirty="0"/>
           </a:p>
           <a:p>
-            <a:pPr algn="ctr" indent="0" marL="0">
+            <a:pPr marL="0" indent="0" algn="ctr">
               <a:buNone/>
             </a:pPr>
             <a:r>
@@ -1622,7 +1381,7 @@
           </a:bodyPr>
           <a:lstStyle/>
           <a:p>
-            <a:pPr algn="ctr" indent="0" marL="0">
+            <a:pPr marL="0" indent="0" algn="ctr">
               <a:buNone/>
             </a:pPr>
             <a:r>
@@ -1639,7 +1398,7 @@
             <a:endParaRPr lang="en-US" sz="1350" dirty="0"/>
           </a:p>
           <a:p>
-            <a:pPr algn="ctr" indent="0" marL="0">
+            <a:pPr marL="0" indent="0" algn="ctr">
               <a:buNone/>
             </a:pPr>
             <a:r>
@@ -1707,7 +1466,7 @@
           </a:bodyPr>
           <a:lstStyle/>
           <a:p>
-            <a:pPr algn="ctr" indent="0" marL="0">
+            <a:pPr marL="0" indent="0" algn="ctr">
               <a:buNone/>
             </a:pPr>
             <a:r>
@@ -1724,7 +1483,7 @@
             <a:endParaRPr lang="en-US" sz="1350" dirty="0"/>
           </a:p>
           <a:p>
-            <a:pPr algn="ctr" indent="0" marL="0">
+            <a:pPr marL="0" indent="0" algn="ctr">
               <a:buNone/>
             </a:pPr>
             <a:r>
@@ -1765,7 +1524,7 @@
           </a:bodyPr>
           <a:lstStyle/>
           <a:p>
-            <a:pPr algn="ctr" indent="0" marL="0">
+            <a:pPr marL="0" indent="0" algn="ctr">
               <a:buNone/>
             </a:pPr>
             <a:r>
@@ -1806,7 +1565,7 @@
           </a:bodyPr>
           <a:lstStyle/>
           <a:p>
-            <a:pPr algn="ctr" indent="0" marL="0">
+            <a:pPr marL="0" indent="0" algn="ctr">
               <a:buNone/>
             </a:pPr>
             <a:r>
@@ -1847,7 +1606,7 @@
           </a:bodyPr>
           <a:lstStyle/>
           <a:p>
-            <a:pPr algn="l" indent="0" marL="0">
+            <a:pPr marL="0" indent="0" algn="l">
               <a:buNone/>
             </a:pPr>
             <a:r>
@@ -1888,7 +1647,7 @@
           </a:bodyPr>
           <a:lstStyle/>
           <a:p>
-            <a:pPr algn="r" indent="0" marL="0">
+            <a:pPr marL="0" indent="0" algn="r">
               <a:buNone/>
             </a:pPr>
             <a:r>
@@ -1922,6 +1681,7 @@
         <a:solidFill>
           <a:srgbClr val="F7F9FA"/>
         </a:solidFill>
+        <a:effectLst/>
       </p:bgPr>
     </p:bg>
     <p:spTree>
@@ -1959,7 +1719,7 @@
           <a:bodyPr wrap="square" lIns="0" tIns="0" rIns="0" bIns="0" rtlCol="0" anchor="ctr"/>
           <a:lstStyle/>
           <a:p>
-            <a:pPr indent="0" marL="0">
+            <a:pPr marL="0" indent="0">
               <a:buNone/>
             </a:pPr>
             <a:r>
@@ -1998,7 +1758,7 @@
           <a:bodyPr wrap="square" lIns="0" tIns="0" rIns="0" bIns="0" rtlCol="0" anchor="ctr"/>
           <a:lstStyle/>
           <a:p>
-            <a:pPr indent="0" marL="0">
+            <a:pPr marL="0" indent="0">
               <a:buNone/>
             </a:pPr>
             <a:r>
@@ -2066,7 +1826,7 @@
           </a:bodyPr>
           <a:lstStyle/>
           <a:p>
-            <a:pPr algn="ctr" indent="0" marL="0">
+            <a:pPr marL="0" indent="0" algn="ctr">
               <a:buNone/>
             </a:pPr>
             <a:r>
@@ -2134,7 +1894,7 @@
           </a:bodyPr>
           <a:lstStyle/>
           <a:p>
-            <a:pPr algn="ctr" indent="0" marL="0">
+            <a:pPr marL="0" indent="0" algn="ctr">
               <a:buNone/>
             </a:pPr>
             <a:r>
@@ -2202,7 +1962,7 @@
           </a:bodyPr>
           <a:lstStyle/>
           <a:p>
-            <a:pPr algn="ctr" indent="0" marL="0">
+            <a:pPr marL="0" indent="0" algn="ctr">
               <a:buNone/>
             </a:pPr>
             <a:r>
@@ -2270,7 +2030,7 @@
           </a:bodyPr>
           <a:lstStyle/>
           <a:p>
-            <a:pPr algn="ctr" indent="0" marL="0">
+            <a:pPr marL="0" indent="0" algn="ctr">
               <a:buNone/>
             </a:pPr>
             <a:r>
@@ -2338,7 +2098,7 @@
           </a:bodyPr>
           <a:lstStyle/>
           <a:p>
-            <a:pPr algn="ctr" indent="0" marL="0">
+            <a:pPr marL="0" indent="0" algn="ctr">
               <a:buNone/>
             </a:pPr>
             <a:r>
@@ -2406,7 +2166,7 @@
           </a:bodyPr>
           <a:lstStyle/>
           <a:p>
-            <a:pPr algn="ctr" indent="0" marL="0">
+            <a:pPr marL="0" indent="0" algn="ctr">
               <a:buNone/>
             </a:pPr>
             <a:r>
@@ -2474,7 +2234,7 @@
           </a:bodyPr>
           <a:lstStyle/>
           <a:p>
-            <a:pPr algn="ctr" indent="0" marL="0">
+            <a:pPr marL="0" indent="0" algn="ctr">
               <a:buNone/>
             </a:pPr>
             <a:r>
@@ -2542,7 +2302,7 @@
           </a:bodyPr>
           <a:lstStyle/>
           <a:p>
-            <a:pPr algn="ctr" indent="0" marL="0">
+            <a:pPr marL="0" indent="0" algn="ctr">
               <a:buNone/>
             </a:pPr>
             <a:r>
@@ -2559,7 +2319,7 @@
             <a:endParaRPr lang="en-US" sz="1100" dirty="0"/>
           </a:p>
           <a:p>
-            <a:pPr algn="ctr" indent="0" marL="0">
+            <a:pPr marL="0" indent="0" algn="ctr">
               <a:buNone/>
             </a:pPr>
             <a:r>
@@ -2627,7 +2387,7 @@
           </a:bodyPr>
           <a:lstStyle/>
           <a:p>
-            <a:pPr algn="ctr" indent="0" marL="0">
+            <a:pPr marL="0" indent="0" algn="ctr">
               <a:buNone/>
             </a:pPr>
             <a:r>
@@ -2654,7 +2414,7 @@
         <p:spPr>
           <a:xfrm>
             <a:off x="2468880" y="1755648"/>
-            <a:ext cx="548640" cy="-493776"/>
+            <a:ext cx="548640" cy="0"/>
           </a:xfrm>
           <a:prstGeom prst="line">
             <a:avLst/>
@@ -2860,7 +2620,7 @@
           </a:bodyPr>
           <a:lstStyle/>
           <a:p>
-            <a:pPr algn="l" indent="0" marL="0">
+            <a:pPr marL="0" indent="0" algn="l">
               <a:buNone/>
             </a:pPr>
             <a:r>
@@ -2901,7 +2661,7 @@
           </a:bodyPr>
           <a:lstStyle/>
           <a:p>
-            <a:pPr algn="l" indent="0" marL="0">
+            <a:pPr marL="0" indent="0" algn="l">
               <a:buNone/>
             </a:pPr>
             <a:r>
@@ -2942,7 +2702,7 @@
           </a:bodyPr>
           <a:lstStyle/>
           <a:p>
-            <a:pPr algn="r" indent="0" marL="0">
+            <a:pPr marL="0" indent="0" algn="r">
               <a:buNone/>
             </a:pPr>
             <a:r>
@@ -2976,6 +2736,7 @@
         <a:solidFill>
           <a:srgbClr val="F7F9FA"/>
         </a:solidFill>
+        <a:effectLst/>
       </p:bgPr>
     </p:bg>
     <p:spTree>
@@ -3013,7 +2774,7 @@
           <a:bodyPr wrap="square" lIns="0" tIns="0" rIns="0" bIns="0" rtlCol="0" anchor="ctr"/>
           <a:lstStyle/>
           <a:p>
-            <a:pPr indent="0" marL="0">
+            <a:pPr marL="0" indent="0">
               <a:buNone/>
             </a:pPr>
             <a:r>
@@ -3052,7 +2813,7 @@
           <a:bodyPr wrap="square" lIns="0" tIns="0" rIns="0" bIns="0" rtlCol="0" anchor="ctr"/>
           <a:lstStyle/>
           <a:p>
-            <a:pPr indent="0" marL="0">
+            <a:pPr marL="0" indent="0">
               <a:buNone/>
             </a:pPr>
             <a:r>
@@ -3120,7 +2881,7 @@
           </a:bodyPr>
           <a:lstStyle/>
           <a:p>
-            <a:pPr algn="ctr" indent="0" marL="0">
+            <a:pPr marL="0" indent="0" algn="ctr">
               <a:buNone/>
             </a:pPr>
             <a:r>
@@ -3212,7 +2973,7 @@
           </a:bodyPr>
           <a:lstStyle/>
           <a:p>
-            <a:pPr algn="ctr" indent="0" marL="0">
+            <a:pPr marL="0" indent="0" algn="ctr">
               <a:buNone/>
             </a:pPr>
             <a:r>
@@ -3304,7 +3065,7 @@
           </a:bodyPr>
           <a:lstStyle/>
           <a:p>
-            <a:pPr algn="ctr" indent="0" marL="0">
+            <a:pPr marL="0" indent="0" algn="ctr">
               <a:buNone/>
             </a:pPr>
             <a:r>
@@ -3396,7 +3157,7 @@
           </a:bodyPr>
           <a:lstStyle/>
           <a:p>
-            <a:pPr algn="ctr" indent="0" marL="0">
+            <a:pPr marL="0" indent="0" algn="ctr">
               <a:buNone/>
             </a:pPr>
             <a:r>
@@ -3488,7 +3249,7 @@
           </a:bodyPr>
           <a:lstStyle/>
           <a:p>
-            <a:pPr algn="ctr" indent="0" marL="0">
+            <a:pPr marL="0" indent="0" algn="ctr">
               <a:buNone/>
             </a:pPr>
             <a:r>
@@ -3529,7 +3290,7 @@
           </a:bodyPr>
           <a:lstStyle/>
           <a:p>
-            <a:pPr algn="l" indent="0" marL="0">
+            <a:pPr marL="0" indent="0" algn="l">
               <a:buNone/>
             </a:pPr>
             <a:r>
@@ -3570,7 +3331,7 @@
           </a:bodyPr>
           <a:lstStyle/>
           <a:p>
-            <a:pPr algn="l" indent="0" marL="0">
+            <a:pPr marL="0" indent="0" algn="l">
               <a:buNone/>
             </a:pPr>
             <a:r>
@@ -3638,7 +3399,7 @@
           </a:bodyPr>
           <a:lstStyle/>
           <a:p>
-            <a:pPr algn="ctr" indent="0" marL="0">
+            <a:pPr marL="0" indent="0" algn="ctr">
               <a:buNone/>
             </a:pPr>
             <a:r>
@@ -3706,7 +3467,7 @@
           </a:bodyPr>
           <a:lstStyle/>
           <a:p>
-            <a:pPr algn="ctr" indent="0" marL="0">
+            <a:pPr marL="0" indent="0" algn="ctr">
               <a:buNone/>
             </a:pPr>
             <a:r>
@@ -3723,7 +3484,7 @@
             <a:endParaRPr lang="en-US" sz="1400" dirty="0"/>
           </a:p>
           <a:p>
-            <a:pPr algn="ctr" indent="0" marL="0">
+            <a:pPr marL="0" indent="0" algn="ctr">
               <a:buNone/>
             </a:pPr>
             <a:r>
@@ -3764,7 +3525,7 @@
           </a:bodyPr>
           <a:lstStyle/>
           <a:p>
-            <a:pPr algn="l" indent="0" marL="0">
+            <a:pPr marL="0" indent="0" algn="l">
               <a:buNone/>
             </a:pPr>
             <a:r>
@@ -3805,7 +3566,7 @@
           </a:bodyPr>
           <a:lstStyle/>
           <a:p>
-            <a:pPr algn="r" indent="0" marL="0">
+            <a:pPr marL="0" indent="0" algn="r">
               <a:buNone/>
             </a:pPr>
             <a:r>
@@ -3839,6 +3600,7 @@
         <a:solidFill>
           <a:srgbClr val="F7F9FA"/>
         </a:solidFill>
+        <a:effectLst/>
       </p:bgPr>
     </p:bg>
     <p:spTree>
@@ -3876,7 +3638,7 @@
           <a:bodyPr wrap="square" lIns="0" tIns="0" rIns="0" bIns="0" rtlCol="0" anchor="ctr"/>
           <a:lstStyle/>
           <a:p>
-            <a:pPr indent="0" marL="0">
+            <a:pPr marL="0" indent="0">
               <a:buNone/>
             </a:pPr>
             <a:r>
@@ -3915,7 +3677,7 @@
           <a:bodyPr wrap="square" lIns="0" tIns="0" rIns="0" bIns="0" rtlCol="0" anchor="ctr"/>
           <a:lstStyle/>
           <a:p>
-            <a:pPr indent="0" marL="0">
+            <a:pPr marL="0" indent="0">
               <a:buNone/>
             </a:pPr>
             <a:r>
@@ -3983,7 +3745,7 @@
           </a:bodyPr>
           <a:lstStyle/>
           <a:p>
-            <a:pPr algn="ctr" indent="0" marL="0">
+            <a:pPr marL="0" indent="0" algn="ctr">
               <a:buNone/>
             </a:pPr>
             <a:r>
@@ -4051,7 +3813,7 @@
           </a:bodyPr>
           <a:lstStyle/>
           <a:p>
-            <a:pPr algn="ctr" indent="0" marL="0">
+            <a:pPr marL="0" indent="0" algn="ctr">
               <a:buNone/>
             </a:pPr>
             <a:r>
@@ -4119,7 +3881,7 @@
           </a:bodyPr>
           <a:lstStyle/>
           <a:p>
-            <a:pPr algn="ctr" indent="0" marL="0">
+            <a:pPr marL="0" indent="0" algn="ctr">
               <a:buNone/>
             </a:pPr>
             <a:r>
@@ -4187,7 +3949,7 @@
           </a:bodyPr>
           <a:lstStyle/>
           <a:p>
-            <a:pPr algn="ctr" indent="0" marL="0">
+            <a:pPr marL="0" indent="0" algn="ctr">
               <a:buNone/>
             </a:pPr>
             <a:r>
@@ -4255,7 +4017,7 @@
           </a:bodyPr>
           <a:lstStyle/>
           <a:p>
-            <a:pPr algn="ctr" indent="0" marL="0">
+            <a:pPr marL="0" indent="0" algn="ctr">
               <a:buNone/>
             </a:pPr>
             <a:r>
@@ -4323,7 +4085,7 @@
           </a:bodyPr>
           <a:lstStyle/>
           <a:p>
-            <a:pPr algn="ctr" indent="0" marL="0">
+            <a:pPr marL="0" indent="0" algn="ctr">
               <a:buNone/>
             </a:pPr>
             <a:r>
@@ -4391,7 +4153,7 @@
           </a:bodyPr>
           <a:lstStyle/>
           <a:p>
-            <a:pPr algn="ctr" indent="0" marL="0">
+            <a:pPr marL="0" indent="0" algn="ctr">
               <a:buNone/>
             </a:pPr>
             <a:r>
@@ -4459,7 +4221,7 @@
           </a:bodyPr>
           <a:lstStyle/>
           <a:p>
-            <a:pPr algn="ctr" indent="0" marL="0">
+            <a:pPr marL="0" indent="0" algn="ctr">
               <a:buNone/>
             </a:pPr>
             <a:r>
@@ -4500,7 +4262,7 @@
           </a:bodyPr>
           <a:lstStyle/>
           <a:p>
-            <a:pPr algn="l" indent="0" marL="0">
+            <a:pPr marL="0" indent="0" algn="l">
               <a:buNone/>
             </a:pPr>
             <a:r>
@@ -4541,7 +4303,7 @@
           </a:bodyPr>
           <a:lstStyle/>
           <a:p>
-            <a:pPr algn="r" indent="0" marL="0">
+            <a:pPr marL="0" indent="0" algn="r">
               <a:buNone/>
             </a:pPr>
             <a:r>
@@ -4575,6 +4337,7 @@
         <a:solidFill>
           <a:srgbClr val="F7F9FA"/>
         </a:solidFill>
+        <a:effectLst/>
       </p:bgPr>
     </p:bg>
     <p:spTree>
@@ -4612,7 +4375,7 @@
           <a:bodyPr wrap="square" lIns="0" tIns="0" rIns="0" bIns="0" rtlCol="0" anchor="ctr"/>
           <a:lstStyle/>
           <a:p>
-            <a:pPr indent="0" marL="0">
+            <a:pPr marL="0" indent="0">
               <a:buNone/>
             </a:pPr>
             <a:r>
@@ -4651,7 +4414,7 @@
           <a:bodyPr wrap="square" lIns="0" tIns="0" rIns="0" bIns="0" rtlCol="0" anchor="ctr"/>
           <a:lstStyle/>
           <a:p>
-            <a:pPr indent="0" marL="0">
+            <a:pPr marL="0" indent="0">
               <a:buNone/>
             </a:pPr>
             <a:r>
@@ -4719,7 +4482,7 @@
           </a:bodyPr>
           <a:lstStyle/>
           <a:p>
-            <a:pPr algn="ctr" indent="0" marL="0">
+            <a:pPr marL="0" indent="0" algn="ctr">
               <a:buNone/>
             </a:pPr>
             <a:r>
@@ -4736,7 +4499,7 @@
             <a:endParaRPr lang="en-US" sz="1200" dirty="0"/>
           </a:p>
           <a:p>
-            <a:pPr algn="ctr" indent="0" marL="0">
+            <a:pPr marL="0" indent="0" algn="ctr">
               <a:buNone/>
             </a:pPr>
             <a:r>
@@ -4804,7 +4567,7 @@
           </a:bodyPr>
           <a:lstStyle/>
           <a:p>
-            <a:pPr algn="ctr" indent="0" marL="0">
+            <a:pPr marL="0" indent="0" algn="ctr">
               <a:buNone/>
             </a:pPr>
             <a:r>
@@ -4821,7 +4584,7 @@
             <a:endParaRPr lang="en-US" sz="1200" dirty="0"/>
           </a:p>
           <a:p>
-            <a:pPr algn="ctr" indent="0" marL="0">
+            <a:pPr marL="0" indent="0" algn="ctr">
               <a:buNone/>
             </a:pPr>
             <a:r>
@@ -4889,7 +4652,7 @@
           </a:bodyPr>
           <a:lstStyle/>
           <a:p>
-            <a:pPr algn="ctr" indent="0" marL="0">
+            <a:pPr marL="0" indent="0" algn="ctr">
               <a:buNone/>
             </a:pPr>
             <a:r>
@@ -4906,7 +4669,7 @@
             <a:endParaRPr lang="en-US" sz="1200" dirty="0"/>
           </a:p>
           <a:p>
-            <a:pPr algn="ctr" indent="0" marL="0">
+            <a:pPr marL="0" indent="0" algn="ctr">
               <a:buNone/>
             </a:pPr>
             <a:r>
@@ -5022,7 +4785,7 @@
           </a:bodyPr>
           <a:lstStyle/>
           <a:p>
-            <a:pPr algn="ctr" indent="0" marL="0">
+            <a:pPr marL="0" indent="0" algn="ctr">
               <a:buNone/>
             </a:pPr>
             <a:r>
@@ -5090,7 +4853,7 @@
           </a:bodyPr>
           <a:lstStyle/>
           <a:p>
-            <a:pPr algn="ctr" indent="0" marL="0">
+            <a:pPr marL="0" indent="0" algn="ctr">
               <a:buNone/>
             </a:pPr>
             <a:r>
@@ -5107,7 +4870,7 @@
             <a:endParaRPr lang="en-US" sz="1200" dirty="0"/>
           </a:p>
           <a:p>
-            <a:pPr algn="ctr" indent="0" marL="0">
+            <a:pPr marL="0" indent="0" algn="ctr">
               <a:buNone/>
             </a:pPr>
             <a:r>
@@ -5175,7 +4938,7 @@
           </a:bodyPr>
           <a:lstStyle/>
           <a:p>
-            <a:pPr algn="ctr" indent="0" marL="0">
+            <a:pPr marL="0" indent="0" algn="ctr">
               <a:buNone/>
             </a:pPr>
             <a:r>
@@ -5216,7 +4979,7 @@
           </a:bodyPr>
           <a:lstStyle/>
           <a:p>
-            <a:pPr algn="ctr" indent="0" marL="0">
+            <a:pPr marL="0" indent="0" algn="ctr">
               <a:buNone/>
             </a:pPr>
             <a:r>
@@ -5257,7 +5020,7 @@
           </a:bodyPr>
           <a:lstStyle/>
           <a:p>
-            <a:pPr algn="l" indent="0" marL="0">
+            <a:pPr marL="0" indent="0" algn="l">
               <a:buNone/>
             </a:pPr>
             <a:r>
@@ -5298,7 +5061,7 @@
           </a:bodyPr>
           <a:lstStyle/>
           <a:p>
-            <a:pPr algn="r" indent="0" marL="0">
+            <a:pPr marL="0" indent="0" algn="r">
               <a:buNone/>
             </a:pPr>
             <a:r>
@@ -5332,6 +5095,7 @@
         <a:solidFill>
           <a:srgbClr val="F7F9FA"/>
         </a:solidFill>
+        <a:effectLst/>
       </p:bgPr>
     </p:bg>
     <p:spTree>
@@ -5369,7 +5133,7 @@
           <a:bodyPr wrap="square" lIns="0" tIns="0" rIns="0" bIns="0" rtlCol="0" anchor="ctr"/>
           <a:lstStyle/>
           <a:p>
-            <a:pPr indent="0" marL="0">
+            <a:pPr marL="0" indent="0">
               <a:buNone/>
             </a:pPr>
             <a:r>
@@ -5408,7 +5172,7 @@
           <a:bodyPr wrap="square" lIns="0" tIns="0" rIns="0" bIns="0" rtlCol="0" anchor="ctr"/>
           <a:lstStyle/>
           <a:p>
-            <a:pPr indent="0" marL="0">
+            <a:pPr marL="0" indent="0">
               <a:buNone/>
             </a:pPr>
             <a:r>
@@ -5476,7 +5240,7 @@
           </a:bodyPr>
           <a:lstStyle/>
           <a:p>
-            <a:pPr algn="ctr" indent="0" marL="0">
+            <a:pPr marL="0" indent="0" algn="ctr">
               <a:buNone/>
             </a:pPr>
             <a:r>
@@ -5544,7 +5308,7 @@
           </a:bodyPr>
           <a:lstStyle/>
           <a:p>
-            <a:pPr algn="ctr" indent="0" marL="0">
+            <a:pPr marL="0" indent="0" algn="ctr">
               <a:buNone/>
             </a:pPr>
             <a:r>
@@ -5612,7 +5376,7 @@
           </a:bodyPr>
           <a:lstStyle/>
           <a:p>
-            <a:pPr algn="ctr" indent="0" marL="0">
+            <a:pPr marL="0" indent="0" algn="ctr">
               <a:buNone/>
             </a:pPr>
             <a:r>
@@ -5680,7 +5444,7 @@
           </a:bodyPr>
           <a:lstStyle/>
           <a:p>
-            <a:pPr algn="ctr" indent="0" marL="0">
+            <a:pPr marL="0" indent="0" algn="ctr">
               <a:buNone/>
             </a:pPr>
             <a:r>
@@ -5748,7 +5512,7 @@
           </a:bodyPr>
           <a:lstStyle/>
           <a:p>
-            <a:pPr algn="ctr" indent="0" marL="0">
+            <a:pPr marL="0" indent="0" algn="ctr">
               <a:buNone/>
             </a:pPr>
             <a:r>
@@ -5816,7 +5580,7 @@
           </a:bodyPr>
           <a:lstStyle/>
           <a:p>
-            <a:pPr algn="ctr" indent="0" marL="0">
+            <a:pPr marL="0" indent="0" algn="ctr">
               <a:buNone/>
             </a:pPr>
             <a:r>
@@ -5884,7 +5648,7 @@
           </a:bodyPr>
           <a:lstStyle/>
           <a:p>
-            <a:pPr algn="ctr" indent="0" marL="0">
+            <a:pPr marL="0" indent="0" algn="ctr">
               <a:buNone/>
             </a:pPr>
             <a:r>
@@ -5952,7 +5716,7 @@
           </a:bodyPr>
           <a:lstStyle/>
           <a:p>
-            <a:pPr algn="ctr" indent="0" marL="0">
+            <a:pPr marL="0" indent="0" algn="ctr">
               <a:buNone/>
             </a:pPr>
             <a:r>
@@ -6020,7 +5784,7 @@
           </a:bodyPr>
           <a:lstStyle/>
           <a:p>
-            <a:pPr algn="ctr" indent="0" marL="0">
+            <a:pPr marL="0" indent="0" algn="ctr">
               <a:buNone/>
             </a:pPr>
             <a:r>
@@ -6088,7 +5852,7 @@
           </a:bodyPr>
           <a:lstStyle/>
           <a:p>
-            <a:pPr algn="ctr" indent="0" marL="0">
+            <a:pPr marL="0" indent="0" algn="ctr">
               <a:buNone/>
             </a:pPr>
             <a:r>
@@ -6156,7 +5920,7 @@
           </a:bodyPr>
           <a:lstStyle/>
           <a:p>
-            <a:pPr algn="ctr" indent="0" marL="0">
+            <a:pPr marL="0" indent="0" algn="ctr">
               <a:buNone/>
             </a:pPr>
             <a:r>
@@ -6224,7 +5988,7 @@
           </a:bodyPr>
           <a:lstStyle/>
           <a:p>
-            <a:pPr algn="ctr" indent="0" marL="0">
+            <a:pPr marL="0" indent="0" algn="ctr">
               <a:buNone/>
             </a:pPr>
             <a:r>
@@ -6292,7 +6056,7 @@
           </a:bodyPr>
           <a:lstStyle/>
           <a:p>
-            <a:pPr algn="ctr" indent="0" marL="0">
+            <a:pPr marL="0" indent="0" algn="ctr">
               <a:buNone/>
             </a:pPr>
             <a:r>
@@ -6360,7 +6124,7 @@
           </a:bodyPr>
           <a:lstStyle/>
           <a:p>
-            <a:pPr algn="ctr" indent="0" marL="0">
+            <a:pPr marL="0" indent="0" algn="ctr">
               <a:buNone/>
             </a:pPr>
             <a:r>
@@ -6428,7 +6192,7 @@
           </a:bodyPr>
           <a:lstStyle/>
           <a:p>
-            <a:pPr algn="ctr" indent="0" marL="0">
+            <a:pPr marL="0" indent="0" algn="ctr">
               <a:buNone/>
             </a:pPr>
             <a:r>
@@ -6496,7 +6260,7 @@
           </a:bodyPr>
           <a:lstStyle/>
           <a:p>
-            <a:pPr algn="ctr" indent="0" marL="0">
+            <a:pPr marL="0" indent="0" algn="ctr">
               <a:buNone/>
             </a:pPr>
             <a:r>
@@ -6564,7 +6328,7 @@
           </a:bodyPr>
           <a:lstStyle/>
           <a:p>
-            <a:pPr algn="ctr" indent="0" marL="0">
+            <a:pPr marL="0" indent="0" algn="ctr">
               <a:buNone/>
             </a:pPr>
             <a:r>
@@ -6632,7 +6396,7 @@
           </a:bodyPr>
           <a:lstStyle/>
           <a:p>
-            <a:pPr algn="ctr" indent="0" marL="0">
+            <a:pPr marL="0" indent="0" algn="ctr">
               <a:buNone/>
             </a:pPr>
             <a:r>
@@ -6700,7 +6464,7 @@
           </a:bodyPr>
           <a:lstStyle/>
           <a:p>
-            <a:pPr algn="ctr" indent="0" marL="0">
+            <a:pPr marL="0" indent="0" algn="ctr">
               <a:buNone/>
             </a:pPr>
             <a:r>
@@ -6768,7 +6532,7 @@
           </a:bodyPr>
           <a:lstStyle/>
           <a:p>
-            <a:pPr algn="ctr" indent="0" marL="0">
+            <a:pPr marL="0" indent="0" algn="ctr">
               <a:buNone/>
             </a:pPr>
             <a:r>
@@ -6836,7 +6600,7 @@
           </a:bodyPr>
           <a:lstStyle/>
           <a:p>
-            <a:pPr algn="ctr" indent="0" marL="0">
+            <a:pPr marL="0" indent="0" algn="ctr">
               <a:buNone/>
             </a:pPr>
             <a:r>
@@ -6877,7 +6641,7 @@
           </a:bodyPr>
           <a:lstStyle/>
           <a:p>
-            <a:pPr algn="ctr" indent="0" marL="0">
+            <a:pPr marL="0" indent="0" algn="ctr">
               <a:buNone/>
             </a:pPr>
             <a:r>
@@ -6918,7 +6682,7 @@
           </a:bodyPr>
           <a:lstStyle/>
           <a:p>
-            <a:pPr algn="l" indent="0" marL="0">
+            <a:pPr marL="0" indent="0" algn="l">
               <a:buNone/>
             </a:pPr>
             <a:r>
@@ -6959,7 +6723,7 @@
           </a:bodyPr>
           <a:lstStyle/>
           <a:p>
-            <a:pPr algn="r" indent="0" marL="0">
+            <a:pPr marL="0" indent="0" algn="r">
               <a:buNone/>
             </a:pPr>
             <a:r>
@@ -6993,6 +6757,7 @@
         <a:solidFill>
           <a:srgbClr val="F7F9FA"/>
         </a:solidFill>
+        <a:effectLst/>
       </p:bgPr>
     </p:bg>
     <p:spTree>
@@ -7030,7 +6795,7 @@
           <a:bodyPr wrap="square" lIns="0" tIns="0" rIns="0" bIns="0" rtlCol="0" anchor="ctr"/>
           <a:lstStyle/>
           <a:p>
-            <a:pPr indent="0" marL="0">
+            <a:pPr marL="0" indent="0">
               <a:buNone/>
             </a:pPr>
             <a:r>
@@ -7069,7 +6834,7 @@
           <a:bodyPr wrap="square" lIns="0" tIns="0" rIns="0" bIns="0" rtlCol="0" anchor="ctr"/>
           <a:lstStyle/>
           <a:p>
-            <a:pPr indent="0" marL="0">
+            <a:pPr marL="0" indent="0">
               <a:buNone/>
             </a:pPr>
             <a:r>
@@ -7137,7 +6902,7 @@
           </a:bodyPr>
           <a:lstStyle/>
           <a:p>
-            <a:pPr algn="ctr" indent="0" marL="0">
+            <a:pPr marL="0" indent="0" algn="ctr">
               <a:buNone/>
             </a:pPr>
             <a:r>
@@ -7205,7 +6970,7 @@
           </a:bodyPr>
           <a:lstStyle/>
           <a:p>
-            <a:pPr algn="ctr" indent="0" marL="0">
+            <a:pPr marL="0" indent="0" algn="ctr">
               <a:buNone/>
             </a:pPr>
             <a:r>
@@ -7273,7 +7038,7 @@
           </a:bodyPr>
           <a:lstStyle/>
           <a:p>
-            <a:pPr algn="ctr" indent="0" marL="0">
+            <a:pPr marL="0" indent="0" algn="ctr">
               <a:buNone/>
             </a:pPr>
             <a:r>
@@ -7341,7 +7106,7 @@
           </a:bodyPr>
           <a:lstStyle/>
           <a:p>
-            <a:pPr algn="ctr" indent="0" marL="0">
+            <a:pPr marL="0" indent="0" algn="ctr">
               <a:buNone/>
             </a:pPr>
             <a:r>
@@ -7382,7 +7147,7 @@
           </a:bodyPr>
           <a:lstStyle/>
           <a:p>
-            <a:pPr algn="l" indent="0" marL="0">
+            <a:pPr marL="0" indent="0" algn="l">
               <a:buNone/>
             </a:pPr>
             <a:r>
@@ -7423,7 +7188,7 @@
           </a:bodyPr>
           <a:lstStyle/>
           <a:p>
-            <a:pPr algn="r" indent="0" marL="0">
+            <a:pPr marL="0" indent="0" algn="r">
               <a:buNone/>
             </a:pPr>
             <a:r>
@@ -7742,4 +7507,299 @@
     </a:ext>
   </a:extLst>
 </a:theme>
+</file>
+
+<file path=ppt/theme/theme2.xml><?xml version="1.0" encoding="utf-8"?>
+<a:theme xmlns:a="http://schemas.openxmlformats.org/drawingml/2006/main" name="Office 테마">
+  <a:themeElements>
+    <a:clrScheme name="Office">
+      <a:dk1>
+        <a:sysClr val="windowText" lastClr="000000"/>
+      </a:dk1>
+      <a:lt1>
+        <a:sysClr val="window" lastClr="FFFFFF"/>
+      </a:lt1>
+      <a:dk2>
+        <a:srgbClr val="44546A"/>
+      </a:dk2>
+      <a:lt2>
+        <a:srgbClr val="E7E6E6"/>
+      </a:lt2>
+      <a:accent1>
+        <a:srgbClr val="4472C4"/>
+      </a:accent1>
+      <a:accent2>
+        <a:srgbClr val="ED7D31"/>
+      </a:accent2>
+      <a:accent3>
+        <a:srgbClr val="A5A5A5"/>
+      </a:accent3>
+      <a:accent4>
+        <a:srgbClr val="FFC000"/>
+      </a:accent4>
+      <a:accent5>
+        <a:srgbClr val="5B9BD5"/>
+      </a:accent5>
+      <a:accent6>
+        <a:srgbClr val="70AD47"/>
+      </a:accent6>
+      <a:hlink>
+        <a:srgbClr val="0563C1"/>
+      </a:hlink>
+      <a:folHlink>
+        <a:srgbClr val="954F72"/>
+      </a:folHlink>
+    </a:clrScheme>
+    <a:fontScheme name="Office">
+      <a:majorFont>
+        <a:latin typeface="맑은 고딕" panose="020F0302020204030204"/>
+        <a:ea typeface=""/>
+        <a:cs typeface=""/>
+        <a:font script="Jpan" typeface="游ゴシック Light"/>
+        <a:font script="Hang" typeface="맑은 고딕"/>
+        <a:font script="Hans" typeface="等线 Light"/>
+        <a:font script="Hant" typeface="新細明體"/>
+        <a:font script="Arab" typeface="Times New Roman"/>
+        <a:font script="Hebr" typeface="Times New Roman"/>
+        <a:font script="Thai" typeface="Angsana New"/>
+        <a:font script="Ethi" typeface="Nyala"/>
+        <a:font script="Beng" typeface="Vrinda"/>
+        <a:font script="Gujr" typeface="Shruti"/>
+        <a:font script="Khmr" typeface="MoolBoran"/>
+        <a:font script="Knda" typeface="Tunga"/>
+        <a:font script="Guru" typeface="Raavi"/>
+        <a:font script="Cans" typeface="Euphemia"/>
+        <a:font script="Cher" typeface="Plantagenet Cherokee"/>
+        <a:font script="Yiii" typeface="Microsoft Yi Baiti"/>
+        <a:font script="Tibt" typeface="Microsoft Himalaya"/>
+        <a:font script="Thaa" typeface="MV Boli"/>
+        <a:font script="Deva" typeface="Mangal"/>
+        <a:font script="Telu" typeface="Gautami"/>
+        <a:font script="Taml" typeface="Latha"/>
+        <a:font script="Syrc" typeface="Estrangelo Edessa"/>
+        <a:font script="Orya" typeface="Kalinga"/>
+        <a:font script="Mlym" typeface="Kartika"/>
+        <a:font script="Laoo" typeface="DokChampa"/>
+        <a:font script="Sinh" typeface="Iskoola Pota"/>
+        <a:font script="Mong" typeface="Mongolian Baiti"/>
+        <a:font script="Viet" typeface="Times New Roman"/>
+        <a:font script="Uigh" typeface="Microsoft Uighur"/>
+        <a:font script="Geor" typeface="Sylfaen"/>
+        <a:font script="Armn" typeface="Arial"/>
+        <a:font script="Bugi" typeface="Leelawadee UI"/>
+        <a:font script="Bopo" typeface="Microsoft JhengHei"/>
+        <a:font script="Java" typeface="Javanese Text"/>
+        <a:font script="Lisu" typeface="Segoe UI"/>
+        <a:font script="Mymr" typeface="Myanmar Text"/>
+        <a:font script="Nkoo" typeface="Ebrima"/>
+        <a:font script="Olck" typeface="Nirmala UI"/>
+        <a:font script="Osma" typeface="Ebrima"/>
+        <a:font script="Phag" typeface="Phagspa"/>
+        <a:font script="Syrn" typeface="Estrangelo Edessa"/>
+        <a:font script="Syrj" typeface="Estrangelo Edessa"/>
+        <a:font script="Syre" typeface="Estrangelo Edessa"/>
+        <a:font script="Sora" typeface="Nirmala UI"/>
+        <a:font script="Tale" typeface="Microsoft Tai Le"/>
+        <a:font script="Talu" typeface="Microsoft New Tai Lue"/>
+        <a:font script="Tfng" typeface="Ebrima"/>
+      </a:majorFont>
+      <a:minorFont>
+        <a:latin typeface="맑은 고딕" panose="020F0502020204030204"/>
+        <a:ea typeface=""/>
+        <a:cs typeface=""/>
+        <a:font script="Jpan" typeface="游ゴシック"/>
+        <a:font script="Hang" typeface="맑은 고딕"/>
+        <a:font script="Hans" typeface="等线"/>
+        <a:font script="Hant" typeface="新細明體"/>
+        <a:font script="Arab" typeface="Arial"/>
+        <a:font script="Hebr" typeface="Arial"/>
+        <a:font script="Thai" typeface="Cordia New"/>
+        <a:font script="Ethi" typeface="Nyala"/>
+        <a:font script="Beng" typeface="Vrinda"/>
+        <a:font script="Gujr" typeface="Shruti"/>
+        <a:font script="Khmr" typeface="DaunPenh"/>
+        <a:font script="Knda" typeface="Tunga"/>
+        <a:font script="Guru" typeface="Raavi"/>
+        <a:font script="Cans" typeface="Euphemia"/>
+        <a:font script="Cher" typeface="Plantagenet Cherokee"/>
+        <a:font script="Yiii" typeface="Microsoft Yi Baiti"/>
+        <a:font script="Tibt" typeface="Microsoft Himalaya"/>
+        <a:font script="Thaa" typeface="MV Boli"/>
+        <a:font script="Deva" typeface="Mangal"/>
+        <a:font script="Telu" typeface="Gautami"/>
+        <a:font script="Taml" typeface="Latha"/>
+        <a:font script="Syrc" typeface="Estrangelo Edessa"/>
+        <a:font script="Orya" typeface="Kalinga"/>
+        <a:font script="Mlym" typeface="Kartika"/>
+        <a:font script="Laoo" typeface="DokChampa"/>
+        <a:font script="Sinh" typeface="Iskoola Pota"/>
+        <a:font script="Mong" typeface="Mongolian Baiti"/>
+        <a:font script="Viet" typeface="Arial"/>
+        <a:font script="Uigh" typeface="Microsoft Uighur"/>
+        <a:font script="Geor" typeface="Sylfaen"/>
+        <a:font script="Armn" typeface="Arial"/>
+        <a:font script="Bugi" typeface="Leelawadee UI"/>
+        <a:font script="Bopo" typeface="Microsoft JhengHei"/>
+        <a:font script="Java" typeface="Javanese Text"/>
+        <a:font script="Lisu" typeface="Segoe UI"/>
+        <a:font script="Mymr" typeface="Myanmar Text"/>
+        <a:font script="Nkoo" typeface="Ebrima"/>
+        <a:font script="Olck" typeface="Nirmala UI"/>
+        <a:font script="Osma" typeface="Ebrima"/>
+        <a:font script="Phag" typeface="Phagspa"/>
+        <a:font script="Syrn" typeface="Estrangelo Edessa"/>
+        <a:font script="Syrj" typeface="Estrangelo Edessa"/>
+        <a:font script="Syre" typeface="Estrangelo Edessa"/>
+        <a:font script="Sora" typeface="Nirmala UI"/>
+        <a:font script="Tale" typeface="Microsoft Tai Le"/>
+        <a:font script="Talu" typeface="Microsoft New Tai Lue"/>
+        <a:font script="Tfng" typeface="Ebrima"/>
+      </a:minorFont>
+    </a:fontScheme>
+    <a:fmtScheme name="Office">
+      <a:fillStyleLst>
+        <a:solidFill>
+          <a:schemeClr val="phClr"/>
+        </a:solidFill>
+        <a:gradFill rotWithShape="1">
+          <a:gsLst>
+            <a:gs pos="0">
+              <a:schemeClr val="phClr">
+                <a:lumMod val="110000"/>
+                <a:satMod val="105000"/>
+                <a:tint val="67000"/>
+              </a:schemeClr>
+            </a:gs>
+            <a:gs pos="50000">
+              <a:schemeClr val="phClr">
+                <a:lumMod val="105000"/>
+                <a:satMod val="103000"/>
+                <a:tint val="73000"/>
+              </a:schemeClr>
+            </a:gs>
+            <a:gs pos="100000">
+              <a:schemeClr val="phClr">
+                <a:lumMod val="105000"/>
+                <a:satMod val="109000"/>
+                <a:tint val="81000"/>
+              </a:schemeClr>
+            </a:gs>
+          </a:gsLst>
+          <a:lin ang="5400000" scaled="0"/>
+        </a:gradFill>
+        <a:gradFill rotWithShape="1">
+          <a:gsLst>
+            <a:gs pos="0">
+              <a:schemeClr val="phClr">
+                <a:satMod val="103000"/>
+                <a:lumMod val="102000"/>
+                <a:tint val="94000"/>
+              </a:schemeClr>
+            </a:gs>
+            <a:gs pos="50000">
+              <a:schemeClr val="phClr">
+                <a:satMod val="110000"/>
+                <a:lumMod val="100000"/>
+                <a:shade val="100000"/>
+              </a:schemeClr>
+            </a:gs>
+            <a:gs pos="100000">
+              <a:schemeClr val="phClr">
+                <a:lumMod val="99000"/>
+                <a:satMod val="120000"/>
+                <a:shade val="78000"/>
+              </a:schemeClr>
+            </a:gs>
+          </a:gsLst>
+          <a:lin ang="5400000" scaled="0"/>
+        </a:gradFill>
+      </a:fillStyleLst>
+      <a:lnStyleLst>
+        <a:ln w="6350" cap="flat" cmpd="sng" algn="ctr">
+          <a:solidFill>
+            <a:schemeClr val="phClr"/>
+          </a:solidFill>
+          <a:prstDash val="solid"/>
+          <a:miter lim="800000"/>
+        </a:ln>
+        <a:ln w="12700" cap="flat" cmpd="sng" algn="ctr">
+          <a:solidFill>
+            <a:schemeClr val="phClr"/>
+          </a:solidFill>
+          <a:prstDash val="solid"/>
+          <a:miter lim="800000"/>
+        </a:ln>
+        <a:ln w="19050" cap="flat" cmpd="sng" algn="ctr">
+          <a:solidFill>
+            <a:schemeClr val="phClr"/>
+          </a:solidFill>
+          <a:prstDash val="solid"/>
+          <a:miter lim="800000"/>
+        </a:ln>
+      </a:lnStyleLst>
+      <a:effectStyleLst>
+        <a:effectStyle>
+          <a:effectLst/>
+        </a:effectStyle>
+        <a:effectStyle>
+          <a:effectLst/>
+        </a:effectStyle>
+        <a:effectStyle>
+          <a:effectLst>
+            <a:outerShdw blurRad="57150" dist="19050" dir="5400000" algn="ctr" rotWithShape="0">
+              <a:srgbClr val="000000">
+                <a:alpha val="63000"/>
+              </a:srgbClr>
+            </a:outerShdw>
+          </a:effectLst>
+        </a:effectStyle>
+      </a:effectStyleLst>
+      <a:bgFillStyleLst>
+        <a:solidFill>
+          <a:schemeClr val="phClr"/>
+        </a:solidFill>
+        <a:solidFill>
+          <a:schemeClr val="phClr">
+            <a:tint val="95000"/>
+            <a:satMod val="170000"/>
+          </a:schemeClr>
+        </a:solidFill>
+        <a:gradFill rotWithShape="1">
+          <a:gsLst>
+            <a:gs pos="0">
+              <a:schemeClr val="phClr">
+                <a:tint val="93000"/>
+                <a:satMod val="150000"/>
+                <a:shade val="98000"/>
+                <a:lumMod val="102000"/>
+              </a:schemeClr>
+            </a:gs>
+            <a:gs pos="50000">
+              <a:schemeClr val="phClr">
+                <a:tint val="98000"/>
+                <a:satMod val="130000"/>
+                <a:shade val="90000"/>
+                <a:lumMod val="103000"/>
+              </a:schemeClr>
+            </a:gs>
+            <a:gs pos="100000">
+              <a:schemeClr val="phClr">
+                <a:shade val="63000"/>
+                <a:satMod val="120000"/>
+              </a:schemeClr>
+            </a:gs>
+          </a:gsLst>
+          <a:lin ang="5400000" scaled="0"/>
+        </a:gradFill>
+      </a:bgFillStyleLst>
+    </a:fmtScheme>
+  </a:themeElements>
+  <a:objectDefaults/>
+  <a:extraClrSchemeLst/>
+  <a:extLst>
+    <a:ext uri="{05A4C25C-085E-4340-85A3-A5531E510DB2}">
+      <thm15:themeFamily xmlns:thm15="http://schemas.microsoft.com/office/thememl/2012/main" name="Office Theme" id="{62F939B6-93AF-4DB8-9C6B-D6C7DFDC589F}" vid="{4A3C46E8-61CC-4603-A589-7422A47A8E4A}"/>
+    </a:ext>
+  </a:extLst>
+</a:theme>
 </file>
</xml_diff>